<commit_message>
Update ETF public reports
</commit_message>
<xml_diff>
--- a/docs/latest_changes.pptx
+++ b/docs/latest_changes.pptx
@@ -374,7 +374,7 @@
                 <a:latin typeface="Malgun Gothic"/>
                 <a:ea typeface="Malgun Gothic"/>
               </a:rPr>
-              <a:t>301</a:t>
+              <a:t>300</a:t>
             </a:r>
             <a:endParaRPr lang="ko-KR" sz="3000"/>
           </a:p>
@@ -512,7 +512,7 @@
                 <a:latin typeface="Malgun Gothic"/>
                 <a:ea typeface="Malgun Gothic"/>
               </a:rPr>
-              <a:t>105</a:t>
+              <a:t>252</a:t>
             </a:r>
             <a:endParaRPr lang="ko-KR" sz="3000"/>
           </a:p>
@@ -650,7 +650,7 @@
                 <a:latin typeface="Malgun Gothic"/>
                 <a:ea typeface="Malgun Gothic"/>
               </a:rPr>
-              <a:t>5165</a:t>
+              <a:t>20877</a:t>
             </a:r>
             <a:endParaRPr lang="ko-KR" sz="3000"/>
           </a:p>
@@ -788,7 +788,7 @@
                 <a:latin typeface="Malgun Gothic"/>
                 <a:ea typeface="Malgun Gothic"/>
               </a:rPr>
-              <a:t>71</a:t>
+              <a:t>107</a:t>
             </a:r>
             <a:endParaRPr lang="ko-KR" sz="3000"/>
           </a:p>
@@ -926,7 +926,7 @@
                 <a:latin typeface="Malgun Gothic"/>
                 <a:ea typeface="Malgun Gothic"/>
               </a:rPr>
-              <a:t>3474</a:t>
+              <a:t>2301</a:t>
             </a:r>
             <a:endParaRPr lang="ko-KR" sz="3000"/>
           </a:p>
@@ -1395,7 +1395,7 @@
                 <a:latin typeface="Malgun Gothic"/>
                 <a:ea typeface="Malgun Gothic"/>
               </a:rPr>
-              <a:t>충격도 200.35pp</a:t>
+              <a:t>충격도 100.35pp</a:t>
             </a:r>
             <a:endParaRPr lang="ko-KR" sz="1800"/>
           </a:p>
@@ -1504,7 +1504,7 @@
                 <a:latin typeface="Malgun Gothic"/>
                 <a:ea typeface="Malgun Gothic"/>
               </a:rPr>
-              <a:t>RISE 2차전지액티브 (422420)</a:t>
+              <a:t>ACE 주주환원가치주액티브 (447430)</a:t>
             </a:r>
             <a:endParaRPr lang="ko-KR" sz="1800"/>
           </a:p>
@@ -1544,7 +1544,7 @@
                 <a:latin typeface="Malgun Gothic"/>
                 <a:ea typeface="Malgun Gothic"/>
               </a:rPr>
-              <a:t>변화 17건 | 매수/증가 1건 | 매도/감소 16건</a:t>
+              <a:t>변화 28건 | 매수/증가 0건 | 매도/감소 27건</a:t>
             </a:r>
             <a:endParaRPr lang="ko-KR" sz="1300"/>
           </a:p>
@@ -1584,7 +1584,7 @@
                 <a:latin typeface="Malgun Gothic"/>
                 <a:ea typeface="Malgun Gothic"/>
               </a:rPr>
-              <a:t>충격도 200.02pp</a:t>
+              <a:t>충격도 100.02pp</a:t>
             </a:r>
             <a:endParaRPr lang="ko-KR" sz="1800"/>
           </a:p>
@@ -1693,7 +1693,7 @@
                 <a:latin typeface="Malgun Gothic"/>
                 <a:ea typeface="Malgun Gothic"/>
               </a:rPr>
-              <a:t>PLUS K제조업핵심기업액티브 (0166S0)</a:t>
+              <a:t>KODEX 로봇액티브 (445290)</a:t>
             </a:r>
             <a:endParaRPr lang="ko-KR" sz="1800"/>
           </a:p>
@@ -1733,7 +1733,7 @@
                 <a:latin typeface="Malgun Gothic"/>
                 <a:ea typeface="Malgun Gothic"/>
               </a:rPr>
-              <a:t>변화 38건 | 매수/증가 1건 | 매도/감소 37건</a:t>
+              <a:t>변화 33건 | 매수/증가 0건 | 매도/감소 33건</a:t>
             </a:r>
             <a:endParaRPr lang="ko-KR" sz="1300"/>
           </a:p>
@@ -1773,7 +1773,7 @@
                 <a:latin typeface="Malgun Gothic"/>
                 <a:ea typeface="Malgun Gothic"/>
               </a:rPr>
-              <a:t>충격도 200.01pp</a:t>
+              <a:t>충격도 100.02pp</a:t>
             </a:r>
             <a:endParaRPr lang="ko-KR" sz="1800"/>
           </a:p>
@@ -1882,7 +1882,7 @@
                 <a:latin typeface="Malgun Gothic"/>
                 <a:ea typeface="Malgun Gothic"/>
               </a:rPr>
-              <a:t>TIME 코스피액티브 (385720)</a:t>
+              <a:t>KoAct K수출핵심기업TOP30액티브 (0074K0)</a:t>
             </a:r>
             <a:endParaRPr lang="ko-KR" sz="1800"/>
           </a:p>
@@ -1922,7 +1922,7 @@
                 <a:latin typeface="Malgun Gothic"/>
                 <a:ea typeface="Malgun Gothic"/>
               </a:rPr>
-              <a:t>변화 27건 | 매수/증가 1건 | 매도/감소 25건</a:t>
+              <a:t>변화 38건 | 매수/증가 0건 | 매도/감소 38건</a:t>
             </a:r>
             <a:endParaRPr lang="ko-KR" sz="1300"/>
           </a:p>
@@ -1962,7 +1962,7 @@
                 <a:latin typeface="Malgun Gothic"/>
                 <a:ea typeface="Malgun Gothic"/>
               </a:rPr>
-              <a:t>충격도 199.90pp</a:t>
+              <a:t>충격도 100.02pp</a:t>
             </a:r>
             <a:endParaRPr lang="ko-KR" sz="1800"/>
           </a:p>
@@ -2071,7 +2071,7 @@
                 <a:latin typeface="Malgun Gothic"/>
                 <a:ea typeface="Malgun Gothic"/>
               </a:rPr>
-              <a:t>TIGER AI코리아그로스액티브 (365040)</a:t>
+              <a:t>KoAct 코리아밸류업액티브 (495230)</a:t>
             </a:r>
             <a:endParaRPr lang="ko-KR" sz="1800"/>
           </a:p>
@@ -2111,7 +2111,7 @@
                 <a:latin typeface="Malgun Gothic"/>
                 <a:ea typeface="Malgun Gothic"/>
               </a:rPr>
-              <a:t>변화 182건 | 매수/증가 1건 | 매도/감소 181건</a:t>
+              <a:t>변화 80건 | 매수/증가 0건 | 매도/감소 78건</a:t>
             </a:r>
             <a:endParaRPr lang="ko-KR" sz="1300"/>
           </a:p>
@@ -2151,7 +2151,7 @@
                 <a:latin typeface="Malgun Gothic"/>
                 <a:ea typeface="Malgun Gothic"/>
               </a:rPr>
-              <a:t>충격도 199.89pp</a:t>
+              <a:t>충격도 100.02pp</a:t>
             </a:r>
             <a:endParaRPr lang="ko-KR" sz="1800"/>
           </a:p>
@@ -2816,7 +2816,7 @@
                 <a:latin typeface="Malgun Gothic"/>
                 <a:ea typeface="Malgun Gothic"/>
               </a:rPr>
-              <a:t>KoAct 코스닥액티브</a:t>
+              <a:t>VITA MZ소비액티브</a:t>
             </a:r>
             <a:endParaRPr lang="ko-KR" sz="1100"/>
           </a:p>
@@ -3023,7 +3023,7 @@
                 <a:latin typeface="Malgun Gothic"/>
                 <a:ea typeface="Malgun Gothic"/>
               </a:rPr>
-              <a:t>-0.18%</a:t>
+              <a:t>2.34%</a:t>
             </a:r>
             <a:endParaRPr lang="ko-KR" sz="1100"/>
           </a:p>
@@ -3092,7 +3092,7 @@
                 <a:latin typeface="Malgun Gothic"/>
                 <a:ea typeface="Malgun Gothic"/>
               </a:rPr>
-              <a:t>100.00%</a:t>
+              <a:t>13.75%</a:t>
             </a:r>
             <a:endParaRPr lang="ko-KR" sz="1100"/>
           </a:p>
@@ -3161,7 +3161,7 @@
                 <a:latin typeface="Malgun Gothic"/>
                 <a:ea typeface="Malgun Gothic"/>
               </a:rPr>
-              <a:t>+100.18pp</a:t>
+              <a:t>+11.41pp</a:t>
             </a:r>
             <a:endParaRPr lang="ko-KR" sz="1100"/>
           </a:p>
@@ -3230,7 +3230,7 @@
                 <a:latin typeface="Malgun Gothic"/>
                 <a:ea typeface="Malgun Gothic"/>
               </a:rPr>
-              <a:t>TIGER AI코리아그로스액티브</a:t>
+              <a:t>VITA 밸류알파액티브</a:t>
             </a:r>
             <a:endParaRPr lang="ko-KR" sz="1100"/>
           </a:p>
@@ -3437,7 +3437,7 @@
                 <a:latin typeface="Malgun Gothic"/>
                 <a:ea typeface="Malgun Gothic"/>
               </a:rPr>
-              <a:t>-0.08%</a:t>
+              <a:t>8.52%</a:t>
             </a:r>
             <a:endParaRPr lang="ko-KR" sz="1100"/>
           </a:p>
@@ -3506,7 +3506,7 @@
                 <a:latin typeface="Malgun Gothic"/>
                 <a:ea typeface="Malgun Gothic"/>
               </a:rPr>
-              <a:t>100.00%</a:t>
+              <a:t>18.11%</a:t>
             </a:r>
             <a:endParaRPr lang="ko-KR" sz="1100"/>
           </a:p>
@@ -3575,7 +3575,7 @@
                 <a:latin typeface="Malgun Gothic"/>
                 <a:ea typeface="Malgun Gothic"/>
               </a:rPr>
-              <a:t>+100.08pp</a:t>
+              <a:t>+9.59pp</a:t>
             </a:r>
             <a:endParaRPr lang="ko-KR" sz="1100"/>
           </a:p>
@@ -3644,7 +3644,7 @@
                 <a:latin typeface="Malgun Gothic"/>
                 <a:ea typeface="Malgun Gothic"/>
               </a:rPr>
-              <a:t>KODEX 200액티브</a:t>
+              <a:t>TIGER 퓨처모빌리티액티브</a:t>
             </a:r>
             <a:endParaRPr lang="ko-KR" sz="1100"/>
           </a:p>
@@ -3713,7 +3713,7 @@
                 <a:latin typeface="Malgun Gothic"/>
                 <a:ea typeface="Malgun Gothic"/>
               </a:rPr>
-              <a:t>증가 원화현금</a:t>
+              <a:t>신규 POSCO홀딩스</a:t>
             </a:r>
             <a:endParaRPr lang="ko-KR" sz="1100"/>
           </a:p>
@@ -3782,7 +3782,7 @@
                 <a:latin typeface="Malgun Gothic"/>
                 <a:ea typeface="Malgun Gothic"/>
               </a:rPr>
-              <a:t>010010</a:t>
+              <a:t>005490</a:t>
             </a:r>
             <a:endParaRPr lang="ko-KR" sz="1100"/>
           </a:p>
@@ -3851,7 +3851,7 @@
                 <a:latin typeface="Malgun Gothic"/>
                 <a:ea typeface="Malgun Gothic"/>
               </a:rPr>
-              <a:t>-0.07%</a:t>
+              <a:t>-</a:t>
             </a:r>
             <a:endParaRPr lang="ko-KR" sz="1100"/>
           </a:p>
@@ -3920,7 +3920,7 @@
                 <a:latin typeface="Malgun Gothic"/>
                 <a:ea typeface="Malgun Gothic"/>
               </a:rPr>
-              <a:t>100.00%</a:t>
+              <a:t>4.00%</a:t>
             </a:r>
             <a:endParaRPr lang="ko-KR" sz="1100"/>
           </a:p>
@@ -3989,7 +3989,7 @@
                 <a:latin typeface="Malgun Gothic"/>
                 <a:ea typeface="Malgun Gothic"/>
               </a:rPr>
-              <a:t>+100.07pp</a:t>
+              <a:t>+4.00pp</a:t>
             </a:r>
             <a:endParaRPr lang="ko-KR" sz="1100"/>
           </a:p>
@@ -4058,7 +4058,7 @@
                 <a:latin typeface="Malgun Gothic"/>
                 <a:ea typeface="Malgun Gothic"/>
               </a:rPr>
-              <a:t>RISE 2차전지액티브</a:t>
+              <a:t>에셋플러스 코리아대장장이액티브</a:t>
             </a:r>
             <a:endParaRPr lang="ko-KR" sz="1100"/>
           </a:p>
@@ -4265,7 +4265,7 @@
                 <a:latin typeface="Malgun Gothic"/>
                 <a:ea typeface="Malgun Gothic"/>
               </a:rPr>
-              <a:t>-0.01%</a:t>
+              <a:t>7.62%</a:t>
             </a:r>
             <a:endParaRPr lang="ko-KR" sz="1100"/>
           </a:p>
@@ -4334,7 +4334,7 @@
                 <a:latin typeface="Malgun Gothic"/>
                 <a:ea typeface="Malgun Gothic"/>
               </a:rPr>
-              <a:t>100.00%</a:t>
+              <a:t>10.82%</a:t>
             </a:r>
             <a:endParaRPr lang="ko-KR" sz="1100"/>
           </a:p>
@@ -4403,7 +4403,7 @@
                 <a:latin typeface="Malgun Gothic"/>
                 <a:ea typeface="Malgun Gothic"/>
               </a:rPr>
-              <a:t>+100.01pp</a:t>
+              <a:t>+3.20pp</a:t>
             </a:r>
             <a:endParaRPr lang="ko-KR" sz="1100"/>
           </a:p>
@@ -4472,7 +4472,7 @@
                 <a:latin typeface="Malgun Gothic"/>
                 <a:ea typeface="Malgun Gothic"/>
               </a:rPr>
-              <a:t>PLUS K제조업핵심기업액티브</a:t>
+              <a:t>TIME K바이오액티브</a:t>
             </a:r>
             <a:endParaRPr lang="ko-KR" sz="1100"/>
           </a:p>
@@ -4679,7 +4679,7 @@
                 <a:latin typeface="Malgun Gothic"/>
                 <a:ea typeface="Malgun Gothic"/>
               </a:rPr>
-              <a:t>0.00%</a:t>
+              <a:t>0.79%</a:t>
             </a:r>
             <a:endParaRPr lang="ko-KR" sz="1100"/>
           </a:p>
@@ -4748,7 +4748,7 @@
                 <a:latin typeface="Malgun Gothic"/>
                 <a:ea typeface="Malgun Gothic"/>
               </a:rPr>
-              <a:t>100.00%</a:t>
+              <a:t>2.72%</a:t>
             </a:r>
             <a:endParaRPr lang="ko-KR" sz="1100"/>
           </a:p>
@@ -4817,7 +4817,7 @@
                 <a:latin typeface="Malgun Gothic"/>
                 <a:ea typeface="Malgun Gothic"/>
               </a:rPr>
-              <a:t>+100.00pp</a:t>
+              <a:t>+1.93pp</a:t>
             </a:r>
             <a:endParaRPr lang="ko-KR" sz="1100"/>
           </a:p>
@@ -4886,7 +4886,7 @@
                 <a:latin typeface="Malgun Gothic"/>
                 <a:ea typeface="Malgun Gothic"/>
               </a:rPr>
-              <a:t>1Q 200액티브</a:t>
+              <a:t>TIME 코스피액티브</a:t>
             </a:r>
             <a:endParaRPr lang="ko-KR" sz="1100"/>
           </a:p>
@@ -4955,7 +4955,7 @@
                 <a:latin typeface="Malgun Gothic"/>
                 <a:ea typeface="Malgun Gothic"/>
               </a:rPr>
-              <a:t>증가 원화현금</a:t>
+              <a:t>신규 신세계</a:t>
             </a:r>
             <a:endParaRPr lang="ko-KR" sz="1100"/>
           </a:p>
@@ -5024,7 +5024,7 @@
                 <a:latin typeface="Malgun Gothic"/>
                 <a:ea typeface="Malgun Gothic"/>
               </a:rPr>
-              <a:t>010010</a:t>
+              <a:t>004170</a:t>
             </a:r>
             <a:endParaRPr lang="ko-KR" sz="1100"/>
           </a:p>
@@ -5093,7 +5093,7 @@
                 <a:latin typeface="Malgun Gothic"/>
                 <a:ea typeface="Malgun Gothic"/>
               </a:rPr>
-              <a:t>0.04%</a:t>
+              <a:t>-</a:t>
             </a:r>
             <a:endParaRPr lang="ko-KR" sz="1100"/>
           </a:p>
@@ -5162,7 +5162,7 @@
                 <a:latin typeface="Malgun Gothic"/>
                 <a:ea typeface="Malgun Gothic"/>
               </a:rPr>
-              <a:t>100.00%</a:t>
+              <a:t>1.61%</a:t>
             </a:r>
             <a:endParaRPr lang="ko-KR" sz="1100"/>
           </a:p>
@@ -5231,7 +5231,7 @@
                 <a:latin typeface="Malgun Gothic"/>
                 <a:ea typeface="Malgun Gothic"/>
               </a:rPr>
-              <a:t>+99.96pp</a:t>
+              <a:t>+1.61pp</a:t>
             </a:r>
             <a:endParaRPr lang="ko-KR" sz="1100"/>
           </a:p>
@@ -5300,7 +5300,7 @@
                 <a:latin typeface="Malgun Gothic"/>
                 <a:ea typeface="Malgun Gothic"/>
               </a:rPr>
-              <a:t>TIME 코스피액티브</a:t>
+              <a:t>TIGER 코리아테크액티브</a:t>
             </a:r>
             <a:endParaRPr lang="ko-KR" sz="1100"/>
           </a:p>
@@ -5369,7 +5369,7 @@
                 <a:latin typeface="Malgun Gothic"/>
                 <a:ea typeface="Malgun Gothic"/>
               </a:rPr>
-              <a:t>증가 원화현금</a:t>
+              <a:t>신규 주성엔지니어링</a:t>
             </a:r>
             <a:endParaRPr lang="ko-KR" sz="1100"/>
           </a:p>
@@ -5438,7 +5438,7 @@
                 <a:latin typeface="Malgun Gothic"/>
                 <a:ea typeface="Malgun Gothic"/>
               </a:rPr>
-              <a:t>010010</a:t>
+              <a:t>036930</a:t>
             </a:r>
             <a:endParaRPr lang="ko-KR" sz="1100"/>
           </a:p>
@@ -5507,7 +5507,7 @@
                 <a:latin typeface="Malgun Gothic"/>
                 <a:ea typeface="Malgun Gothic"/>
               </a:rPr>
-              <a:t>0.06%</a:t>
+              <a:t>-</a:t>
             </a:r>
             <a:endParaRPr lang="ko-KR" sz="1100"/>
           </a:p>
@@ -5576,7 +5576,7 @@
                 <a:latin typeface="Malgun Gothic"/>
                 <a:ea typeface="Malgun Gothic"/>
               </a:rPr>
-              <a:t>100.00%</a:t>
+              <a:t>1.29%</a:t>
             </a:r>
             <a:endParaRPr lang="ko-KR" sz="1100"/>
           </a:p>
@@ -5645,7 +5645,7 @@
                 <a:latin typeface="Malgun Gothic"/>
                 <a:ea typeface="Malgun Gothic"/>
               </a:rPr>
-              <a:t>+99.94pp</a:t>
+              <a:t>+1.29pp</a:t>
             </a:r>
             <a:endParaRPr lang="ko-KR" sz="1100"/>
           </a:p>
@@ -5714,7 +5714,7 @@
                 <a:latin typeface="Malgun Gothic"/>
                 <a:ea typeface="Malgun Gothic"/>
               </a:rPr>
-              <a:t>ACE K수출핵심TOP10산업액티</a:t>
+              <a:t>TIGER 퓨처모빌리티액티브</a:t>
             </a:r>
             <a:endParaRPr lang="ko-KR" sz="1100"/>
           </a:p>
@@ -5783,7 +5783,7 @@
                 <a:latin typeface="Malgun Gothic"/>
                 <a:ea typeface="Malgun Gothic"/>
               </a:rPr>
-              <a:t>증가 원화현금</a:t>
+              <a:t>증가 LG에너지솔루션</a:t>
             </a:r>
             <a:endParaRPr lang="ko-KR" sz="1100"/>
           </a:p>
@@ -5852,7 +5852,7 @@
                 <a:latin typeface="Malgun Gothic"/>
                 <a:ea typeface="Malgun Gothic"/>
               </a:rPr>
-              <a:t>010010</a:t>
+              <a:t>373220</a:t>
             </a:r>
             <a:endParaRPr lang="ko-KR" sz="1100"/>
           </a:p>
@@ -5921,7 +5921,7 @@
                 <a:latin typeface="Malgun Gothic"/>
                 <a:ea typeface="Malgun Gothic"/>
               </a:rPr>
-              <a:t>0.27%</a:t>
+              <a:t>5.96%</a:t>
             </a:r>
             <a:endParaRPr lang="ko-KR" sz="1100"/>
           </a:p>
@@ -5990,7 +5990,7 @@
                 <a:latin typeface="Malgun Gothic"/>
                 <a:ea typeface="Malgun Gothic"/>
               </a:rPr>
-              <a:t>100.00%</a:t>
+              <a:t>7.16%</a:t>
             </a:r>
             <a:endParaRPr lang="ko-KR" sz="1100"/>
           </a:p>
@@ -6059,7 +6059,7 @@
                 <a:latin typeface="Malgun Gothic"/>
                 <a:ea typeface="Malgun Gothic"/>
               </a:rPr>
-              <a:t>+99.73pp</a:t>
+              <a:t>+1.20pp</a:t>
             </a:r>
             <a:endParaRPr lang="ko-KR" sz="1100"/>
           </a:p>
@@ -6128,7 +6128,7 @@
                 <a:latin typeface="Malgun Gothic"/>
                 <a:ea typeface="Malgun Gothic"/>
               </a:rPr>
-              <a:t>KoAct K수출핵심기업TOP30</a:t>
+              <a:t>TIGER 퓨처모빌리티액티브</a:t>
             </a:r>
             <a:endParaRPr lang="ko-KR" sz="1100"/>
           </a:p>
@@ -6197,7 +6197,7 @@
                 <a:latin typeface="Malgun Gothic"/>
                 <a:ea typeface="Malgun Gothic"/>
               </a:rPr>
-              <a:t>증가 원화현금</a:t>
+              <a:t>증가 에코프로비엠</a:t>
             </a:r>
             <a:endParaRPr lang="ko-KR" sz="1100"/>
           </a:p>
@@ -6266,7 +6266,7 @@
                 <a:latin typeface="Malgun Gothic"/>
                 <a:ea typeface="Malgun Gothic"/>
               </a:rPr>
-              <a:t>010010</a:t>
+              <a:t>247540</a:t>
             </a:r>
             <a:endParaRPr lang="ko-KR" sz="1100"/>
           </a:p>
@@ -6335,7 +6335,7 @@
                 <a:latin typeface="Malgun Gothic"/>
                 <a:ea typeface="Malgun Gothic"/>
               </a:rPr>
-              <a:t>0.29%</a:t>
+              <a:t>3.88%</a:t>
             </a:r>
             <a:endParaRPr lang="ko-KR" sz="1100"/>
           </a:p>
@@ -6404,7 +6404,7 @@
                 <a:latin typeface="Malgun Gothic"/>
                 <a:ea typeface="Malgun Gothic"/>
               </a:rPr>
-              <a:t>100.00%</a:t>
+              <a:t>4.86%</a:t>
             </a:r>
             <a:endParaRPr lang="ko-KR" sz="1100"/>
           </a:p>
@@ -6473,7 +6473,7 @@
                 <a:latin typeface="Malgun Gothic"/>
                 <a:ea typeface="Malgun Gothic"/>
               </a:rPr>
-              <a:t>+99.71pp</a:t>
+              <a:t>+0.98pp</a:t>
             </a:r>
             <a:endParaRPr lang="ko-KR" sz="1100"/>
           </a:p>
@@ -6542,7 +6542,7 @@
                 <a:latin typeface="Malgun Gothic"/>
                 <a:ea typeface="Malgun Gothic"/>
               </a:rPr>
-              <a:t>마이티 다이나믹퀀트액티브</a:t>
+              <a:t>TIGER 코리아테크액티브</a:t>
             </a:r>
             <a:endParaRPr lang="ko-KR" sz="1100"/>
           </a:p>
@@ -6611,7 +6611,7 @@
                 <a:latin typeface="Malgun Gothic"/>
                 <a:ea typeface="Malgun Gothic"/>
               </a:rPr>
-              <a:t>증가 원화현금</a:t>
+              <a:t>증가 나노신소재</a:t>
             </a:r>
             <a:endParaRPr lang="ko-KR" sz="1100"/>
           </a:p>
@@ -6680,7 +6680,7 @@
                 <a:latin typeface="Malgun Gothic"/>
                 <a:ea typeface="Malgun Gothic"/>
               </a:rPr>
-              <a:t>010010</a:t>
+              <a:t>121600</a:t>
             </a:r>
             <a:endParaRPr lang="ko-KR" sz="1100"/>
           </a:p>
@@ -6749,7 +6749,7 @@
                 <a:latin typeface="Malgun Gothic"/>
                 <a:ea typeface="Malgun Gothic"/>
               </a:rPr>
-              <a:t>0.29%</a:t>
+              <a:t>1.00%</a:t>
             </a:r>
             <a:endParaRPr lang="ko-KR" sz="1100"/>
           </a:p>
@@ -6818,7 +6818,7 @@
                 <a:latin typeface="Malgun Gothic"/>
                 <a:ea typeface="Malgun Gothic"/>
               </a:rPr>
-              <a:t>100.00%</a:t>
+              <a:t>1.97%</a:t>
             </a:r>
             <a:endParaRPr lang="ko-KR" sz="1100"/>
           </a:p>
@@ -6887,7 +6887,7 @@
                 <a:latin typeface="Malgun Gothic"/>
                 <a:ea typeface="Malgun Gothic"/>
               </a:rPr>
-              <a:t>+99.71pp</a:t>
+              <a:t>+0.97pp</a:t>
             </a:r>
             <a:endParaRPr lang="ko-KR" sz="1100"/>
           </a:p>
@@ -7552,7 +7552,7 @@
                 <a:latin typeface="Malgun Gothic"/>
                 <a:ea typeface="Malgun Gothic"/>
               </a:rPr>
-              <a:t>KODEX 200액티브</a:t>
+              <a:t>1Q CD금리액티브(합성)</a:t>
             </a:r>
             <a:endParaRPr lang="ko-KR" sz="1100"/>
           </a:p>
@@ -7621,7 +7621,7 @@
                 <a:latin typeface="Malgun Gothic"/>
                 <a:ea typeface="Malgun Gothic"/>
               </a:rPr>
-              <a:t>감소 삼성전자</a:t>
+              <a:t>감소 원화현금</a:t>
             </a:r>
             <a:endParaRPr lang="ko-KR" sz="1100"/>
           </a:p>
@@ -7690,7 +7690,7 @@
                 <a:latin typeface="Malgun Gothic"/>
                 <a:ea typeface="Malgun Gothic"/>
               </a:rPr>
-              <a:t>005930</a:t>
+              <a:t>010010</a:t>
             </a:r>
             <a:endParaRPr lang="ko-KR" sz="1100"/>
           </a:p>
@@ -7759,7 +7759,7 @@
                 <a:latin typeface="Malgun Gothic"/>
                 <a:ea typeface="Malgun Gothic"/>
               </a:rPr>
-              <a:t>31.85%</a:t>
+              <a:t>100.00%</a:t>
             </a:r>
             <a:endParaRPr lang="ko-KR" sz="1100"/>
           </a:p>
@@ -7828,7 +7828,7 @@
                 <a:latin typeface="Malgun Gothic"/>
                 <a:ea typeface="Malgun Gothic"/>
               </a:rPr>
-              <a:t>0.00%</a:t>
+              <a:t>-</a:t>
             </a:r>
             <a:endParaRPr lang="ko-KR" sz="1100"/>
           </a:p>
@@ -7897,7 +7897,7 @@
                 <a:latin typeface="Malgun Gothic"/>
                 <a:ea typeface="Malgun Gothic"/>
               </a:rPr>
-              <a:t>-31.85pp</a:t>
+              <a:t>-100.00pp</a:t>
             </a:r>
             <a:endParaRPr lang="ko-KR" sz="1100"/>
           </a:p>
@@ -7966,7 +7966,7 @@
                 <a:latin typeface="Malgun Gothic"/>
                 <a:ea typeface="Malgun Gothic"/>
               </a:rPr>
-              <a:t>1Q 200액티브</a:t>
+              <a:t>HANARO KOFR금리액티브(합</a:t>
             </a:r>
             <a:endParaRPr lang="ko-KR" sz="1100"/>
           </a:p>
@@ -8035,7 +8035,7 @@
                 <a:latin typeface="Malgun Gothic"/>
                 <a:ea typeface="Malgun Gothic"/>
               </a:rPr>
-              <a:t>감소 삼성전자</a:t>
+              <a:t>감소 원화현금</a:t>
             </a:r>
             <a:endParaRPr lang="ko-KR" sz="1100"/>
           </a:p>
@@ -8104,7 +8104,7 @@
                 <a:latin typeface="Malgun Gothic"/>
                 <a:ea typeface="Malgun Gothic"/>
               </a:rPr>
-              <a:t>005930</a:t>
+              <a:t>010010</a:t>
             </a:r>
             <a:endParaRPr lang="ko-KR" sz="1100"/>
           </a:p>
@@ -8173,7 +8173,7 @@
                 <a:latin typeface="Malgun Gothic"/>
                 <a:ea typeface="Malgun Gothic"/>
               </a:rPr>
-              <a:t>31.62%</a:t>
+              <a:t>100.00%</a:t>
             </a:r>
             <a:endParaRPr lang="ko-KR" sz="1100"/>
           </a:p>
@@ -8242,7 +8242,7 @@
                 <a:latin typeface="Malgun Gothic"/>
                 <a:ea typeface="Malgun Gothic"/>
               </a:rPr>
-              <a:t>0.00%</a:t>
+              <a:t>-</a:t>
             </a:r>
             <a:endParaRPr lang="ko-KR" sz="1100"/>
           </a:p>
@@ -8311,7 +8311,7 @@
                 <a:latin typeface="Malgun Gothic"/>
                 <a:ea typeface="Malgun Gothic"/>
               </a:rPr>
-              <a:t>-31.62pp</a:t>
+              <a:t>-100.00pp</a:t>
             </a:r>
             <a:endParaRPr lang="ko-KR" sz="1100"/>
           </a:p>
@@ -8380,7 +8380,7 @@
                 <a:latin typeface="Malgun Gothic"/>
                 <a:ea typeface="Malgun Gothic"/>
               </a:rPr>
-              <a:t>TIGER 반도체TOP10커버드콜</a:t>
+              <a:t>KIWOOM CD금리액티브(합성)</a:t>
             </a:r>
             <a:endParaRPr lang="ko-KR" sz="1100"/>
           </a:p>
@@ -8449,7 +8449,7 @@
                 <a:latin typeface="Malgun Gothic"/>
                 <a:ea typeface="Malgun Gothic"/>
               </a:rPr>
-              <a:t>감소 SK하이닉스</a:t>
+              <a:t>감소 원화현금</a:t>
             </a:r>
             <a:endParaRPr lang="ko-KR" sz="1100"/>
           </a:p>
@@ -8518,7 +8518,7 @@
                 <a:latin typeface="Malgun Gothic"/>
                 <a:ea typeface="Malgun Gothic"/>
               </a:rPr>
-              <a:t>000660</a:t>
+              <a:t>010010</a:t>
             </a:r>
             <a:endParaRPr lang="ko-KR" sz="1100"/>
           </a:p>
@@ -8587,7 +8587,7 @@
                 <a:latin typeface="Malgun Gothic"/>
                 <a:ea typeface="Malgun Gothic"/>
               </a:rPr>
-              <a:t>28.53%</a:t>
+              <a:t>100.00%</a:t>
             </a:r>
             <a:endParaRPr lang="ko-KR" sz="1100"/>
           </a:p>
@@ -8656,7 +8656,7 @@
                 <a:latin typeface="Malgun Gothic"/>
                 <a:ea typeface="Malgun Gothic"/>
               </a:rPr>
-              <a:t>0.00%</a:t>
+              <a:t>-</a:t>
             </a:r>
             <a:endParaRPr lang="ko-KR" sz="1100"/>
           </a:p>
@@ -8725,7 +8725,7 @@
                 <a:latin typeface="Malgun Gothic"/>
                 <a:ea typeface="Malgun Gothic"/>
               </a:rPr>
-              <a:t>-28.53pp</a:t>
+              <a:t>-100.00pp</a:t>
             </a:r>
             <a:endParaRPr lang="ko-KR" sz="1100"/>
           </a:p>
@@ -8794,7 +8794,7 @@
                 <a:latin typeface="Malgun Gothic"/>
                 <a:ea typeface="Malgun Gothic"/>
               </a:rPr>
-              <a:t>HK 베스트일레븐액티브</a:t>
+              <a:t>KODEX CD1년금리플러스액티브</a:t>
             </a:r>
             <a:endParaRPr lang="ko-KR" sz="1100"/>
           </a:p>
@@ -8863,7 +8863,7 @@
                 <a:latin typeface="Malgun Gothic"/>
                 <a:ea typeface="Malgun Gothic"/>
               </a:rPr>
-              <a:t>감소 삼성전자</a:t>
+              <a:t>감소 원화현금</a:t>
             </a:r>
             <a:endParaRPr lang="ko-KR" sz="1100"/>
           </a:p>
@@ -8932,7 +8932,7 @@
                 <a:latin typeface="Malgun Gothic"/>
                 <a:ea typeface="Malgun Gothic"/>
               </a:rPr>
-              <a:t>005930</a:t>
+              <a:t>010010</a:t>
             </a:r>
             <a:endParaRPr lang="ko-KR" sz="1100"/>
           </a:p>
@@ -9001,7 +9001,7 @@
                 <a:latin typeface="Malgun Gothic"/>
                 <a:ea typeface="Malgun Gothic"/>
               </a:rPr>
-              <a:t>27.63%</a:t>
+              <a:t>100.00%</a:t>
             </a:r>
             <a:endParaRPr lang="ko-KR" sz="1100"/>
           </a:p>
@@ -9070,7 +9070,7 @@
                 <a:latin typeface="Malgun Gothic"/>
                 <a:ea typeface="Malgun Gothic"/>
               </a:rPr>
-              <a:t>0.00%</a:t>
+              <a:t>-</a:t>
             </a:r>
             <a:endParaRPr lang="ko-KR" sz="1100"/>
           </a:p>
@@ -9139,7 +9139,7 @@
                 <a:latin typeface="Malgun Gothic"/>
                 <a:ea typeface="Malgun Gothic"/>
               </a:rPr>
-              <a:t>-27.63pp</a:t>
+              <a:t>-100.00pp</a:t>
             </a:r>
             <a:endParaRPr lang="ko-KR" sz="1100"/>
           </a:p>
@@ -9208,7 +9208,7 @@
                 <a:latin typeface="Malgun Gothic"/>
                 <a:ea typeface="Malgun Gothic"/>
               </a:rPr>
-              <a:t>TIME 코리아밸류업액티브</a:t>
+              <a:t>KODEX KOFR금리액티브(합성</a:t>
             </a:r>
             <a:endParaRPr lang="ko-KR" sz="1100"/>
           </a:p>
@@ -9277,7 +9277,7 @@
                 <a:latin typeface="Malgun Gothic"/>
                 <a:ea typeface="Malgun Gothic"/>
               </a:rPr>
-              <a:t>감소 SK하이닉스</a:t>
+              <a:t>감소 원화현금</a:t>
             </a:r>
             <a:endParaRPr lang="ko-KR" sz="1100"/>
           </a:p>
@@ -9346,7 +9346,7 @@
                 <a:latin typeface="Malgun Gothic"/>
                 <a:ea typeface="Malgun Gothic"/>
               </a:rPr>
-              <a:t>000660</a:t>
+              <a:t>010010</a:t>
             </a:r>
             <a:endParaRPr lang="ko-KR" sz="1100"/>
           </a:p>
@@ -9415,7 +9415,7 @@
                 <a:latin typeface="Malgun Gothic"/>
                 <a:ea typeface="Malgun Gothic"/>
               </a:rPr>
-              <a:t>27.01%</a:t>
+              <a:t>100.00%</a:t>
             </a:r>
             <a:endParaRPr lang="ko-KR" sz="1100"/>
           </a:p>
@@ -9484,7 +9484,7 @@
                 <a:latin typeface="Malgun Gothic"/>
                 <a:ea typeface="Malgun Gothic"/>
               </a:rPr>
-              <a:t>0.00%</a:t>
+              <a:t>-</a:t>
             </a:r>
             <a:endParaRPr lang="ko-KR" sz="1100"/>
           </a:p>
@@ -9553,7 +9553,7 @@
                 <a:latin typeface="Malgun Gothic"/>
                 <a:ea typeface="Malgun Gothic"/>
               </a:rPr>
-              <a:t>-27.01pp</a:t>
+              <a:t>-100.00pp</a:t>
             </a:r>
             <a:endParaRPr lang="ko-KR" sz="1100"/>
           </a:p>
@@ -9622,7 +9622,7 @@
                 <a:latin typeface="Malgun Gothic"/>
                 <a:ea typeface="Malgun Gothic"/>
               </a:rPr>
-              <a:t>마이티 다이나믹퀀트액티브</a:t>
+              <a:t>RISE CD금리액티브(합성)</a:t>
             </a:r>
             <a:endParaRPr lang="ko-KR" sz="1100"/>
           </a:p>
@@ -9691,7 +9691,7 @@
                 <a:latin typeface="Malgun Gothic"/>
                 <a:ea typeface="Malgun Gothic"/>
               </a:rPr>
-              <a:t>감소 삼성전자</a:t>
+              <a:t>감소 원화현금</a:t>
             </a:r>
             <a:endParaRPr lang="ko-KR" sz="1100"/>
           </a:p>
@@ -9760,7 +9760,7 @@
                 <a:latin typeface="Malgun Gothic"/>
                 <a:ea typeface="Malgun Gothic"/>
               </a:rPr>
-              <a:t>005930</a:t>
+              <a:t>010010</a:t>
             </a:r>
             <a:endParaRPr lang="ko-KR" sz="1100"/>
           </a:p>
@@ -9829,7 +9829,7 @@
                 <a:latin typeface="Malgun Gothic"/>
                 <a:ea typeface="Malgun Gothic"/>
               </a:rPr>
-              <a:t>26.25%</a:t>
+              <a:t>100.00%</a:t>
             </a:r>
             <a:endParaRPr lang="ko-KR" sz="1100"/>
           </a:p>
@@ -9898,7 +9898,7 @@
                 <a:latin typeface="Malgun Gothic"/>
                 <a:ea typeface="Malgun Gothic"/>
               </a:rPr>
-              <a:t>0.00%</a:t>
+              <a:t>-</a:t>
             </a:r>
             <a:endParaRPr lang="ko-KR" sz="1100"/>
           </a:p>
@@ -9967,7 +9967,7 @@
                 <a:latin typeface="Malgun Gothic"/>
                 <a:ea typeface="Malgun Gothic"/>
               </a:rPr>
-              <a:t>-26.25pp</a:t>
+              <a:t>-100.00pp</a:t>
             </a:r>
             <a:endParaRPr lang="ko-KR" sz="1100"/>
           </a:p>
@@ -10036,7 +10036,7 @@
                 <a:latin typeface="Malgun Gothic"/>
                 <a:ea typeface="Malgun Gothic"/>
               </a:rPr>
-              <a:t>TIGER AI코리아그로스액티브</a:t>
+              <a:t>RISE KOFR금리액티브(합성)</a:t>
             </a:r>
             <a:endParaRPr lang="ko-KR" sz="1100"/>
           </a:p>
@@ -10105,7 +10105,7 @@
                 <a:latin typeface="Malgun Gothic"/>
                 <a:ea typeface="Malgun Gothic"/>
               </a:rPr>
-              <a:t>감소 삼성전자</a:t>
+              <a:t>감소 원화현금</a:t>
             </a:r>
             <a:endParaRPr lang="ko-KR" sz="1100"/>
           </a:p>
@@ -10174,7 +10174,7 @@
                 <a:latin typeface="Malgun Gothic"/>
                 <a:ea typeface="Malgun Gothic"/>
               </a:rPr>
-              <a:t>005930</a:t>
+              <a:t>010010</a:t>
             </a:r>
             <a:endParaRPr lang="ko-KR" sz="1100"/>
           </a:p>
@@ -10243,7 +10243,7 @@
                 <a:latin typeface="Malgun Gothic"/>
                 <a:ea typeface="Malgun Gothic"/>
               </a:rPr>
-              <a:t>25.73%</a:t>
+              <a:t>100.00%</a:t>
             </a:r>
             <a:endParaRPr lang="ko-KR" sz="1100"/>
           </a:p>
@@ -10312,7 +10312,7 @@
                 <a:latin typeface="Malgun Gothic"/>
                 <a:ea typeface="Malgun Gothic"/>
               </a:rPr>
-              <a:t>0.00%</a:t>
+              <a:t>-</a:t>
             </a:r>
             <a:endParaRPr lang="ko-KR" sz="1100"/>
           </a:p>
@@ -10381,7 +10381,7 @@
                 <a:latin typeface="Malgun Gothic"/>
                 <a:ea typeface="Malgun Gothic"/>
               </a:rPr>
-              <a:t>-25.73pp</a:t>
+              <a:t>-100.00pp</a:t>
             </a:r>
             <a:endParaRPr lang="ko-KR" sz="1100"/>
           </a:p>
@@ -10450,7 +10450,7 @@
                 <a:latin typeface="Malgun Gothic"/>
                 <a:ea typeface="Malgun Gothic"/>
               </a:rPr>
-              <a:t>마이다스 코스피액티브</a:t>
+              <a:t>TIGER CD1년금리액티브(합성</a:t>
             </a:r>
             <a:endParaRPr lang="ko-KR" sz="1100"/>
           </a:p>
@@ -10519,7 +10519,7 @@
                 <a:latin typeface="Malgun Gothic"/>
                 <a:ea typeface="Malgun Gothic"/>
               </a:rPr>
-              <a:t>감소 삼성전자</a:t>
+              <a:t>감소 원화현금</a:t>
             </a:r>
             <a:endParaRPr lang="ko-KR" sz="1100"/>
           </a:p>
@@ -10588,7 +10588,7 @@
                 <a:latin typeface="Malgun Gothic"/>
                 <a:ea typeface="Malgun Gothic"/>
               </a:rPr>
-              <a:t>005930</a:t>
+              <a:t>010010</a:t>
             </a:r>
             <a:endParaRPr lang="ko-KR" sz="1100"/>
           </a:p>
@@ -10657,7 +10657,7 @@
                 <a:latin typeface="Malgun Gothic"/>
                 <a:ea typeface="Malgun Gothic"/>
               </a:rPr>
-              <a:t>25.27%</a:t>
+              <a:t>100.00%</a:t>
             </a:r>
             <a:endParaRPr lang="ko-KR" sz="1100"/>
           </a:p>
@@ -10726,7 +10726,7 @@
                 <a:latin typeface="Malgun Gothic"/>
                 <a:ea typeface="Malgun Gothic"/>
               </a:rPr>
-              <a:t>0.00%</a:t>
+              <a:t>-</a:t>
             </a:r>
             <a:endParaRPr lang="ko-KR" sz="1100"/>
           </a:p>
@@ -10795,7 +10795,7 @@
                 <a:latin typeface="Malgun Gothic"/>
                 <a:ea typeface="Malgun Gothic"/>
               </a:rPr>
-              <a:t>-25.27pp</a:t>
+              <a:t>-100.00pp</a:t>
             </a:r>
             <a:endParaRPr lang="ko-KR" sz="1100"/>
           </a:p>
@@ -10864,7 +10864,7 @@
                 <a:latin typeface="Malgun Gothic"/>
                 <a:ea typeface="Malgun Gothic"/>
               </a:rPr>
-              <a:t>ACE 라이프자산주주가치액티브</a:t>
+              <a:t>TIGER CD금리플러스액티브(합</a:t>
             </a:r>
             <a:endParaRPr lang="ko-KR" sz="1100"/>
           </a:p>
@@ -10933,7 +10933,7 @@
                 <a:latin typeface="Malgun Gothic"/>
                 <a:ea typeface="Malgun Gothic"/>
               </a:rPr>
-              <a:t>감소 삼성전자</a:t>
+              <a:t>감소 원화현금</a:t>
             </a:r>
             <a:endParaRPr lang="ko-KR" sz="1100"/>
           </a:p>
@@ -11002,7 +11002,7 @@
                 <a:latin typeface="Malgun Gothic"/>
                 <a:ea typeface="Malgun Gothic"/>
               </a:rPr>
-              <a:t>005930</a:t>
+              <a:t>010010</a:t>
             </a:r>
             <a:endParaRPr lang="ko-KR" sz="1100"/>
           </a:p>
@@ -11071,7 +11071,7 @@
                 <a:latin typeface="Malgun Gothic"/>
                 <a:ea typeface="Malgun Gothic"/>
               </a:rPr>
-              <a:t>25.13%</a:t>
+              <a:t>100.00%</a:t>
             </a:r>
             <a:endParaRPr lang="ko-KR" sz="1100"/>
           </a:p>
@@ -11140,7 +11140,7 @@
                 <a:latin typeface="Malgun Gothic"/>
                 <a:ea typeface="Malgun Gothic"/>
               </a:rPr>
-              <a:t>0.00%</a:t>
+              <a:t>-</a:t>
             </a:r>
             <a:endParaRPr lang="ko-KR" sz="1100"/>
           </a:p>
@@ -11209,7 +11209,7 @@
                 <a:latin typeface="Malgun Gothic"/>
                 <a:ea typeface="Malgun Gothic"/>
               </a:rPr>
-              <a:t>-25.13pp</a:t>
+              <a:t>-100.00pp</a:t>
             </a:r>
             <a:endParaRPr lang="ko-KR" sz="1100"/>
           </a:p>
@@ -11278,7 +11278,7 @@
                 <a:latin typeface="Malgun Gothic"/>
                 <a:ea typeface="Malgun Gothic"/>
               </a:rPr>
-              <a:t>KoAct 코리아밸류업액티브</a:t>
+              <a:t>TIGER KOFR금리액티브(합성</a:t>
             </a:r>
             <a:endParaRPr lang="ko-KR" sz="1100"/>
           </a:p>
@@ -11347,7 +11347,7 @@
                 <a:latin typeface="Malgun Gothic"/>
                 <a:ea typeface="Malgun Gothic"/>
               </a:rPr>
-              <a:t>감소 SK하이닉스</a:t>
+              <a:t>감소 원화현금</a:t>
             </a:r>
             <a:endParaRPr lang="ko-KR" sz="1100"/>
           </a:p>
@@ -11416,7 +11416,7 @@
                 <a:latin typeface="Malgun Gothic"/>
                 <a:ea typeface="Malgun Gothic"/>
               </a:rPr>
-              <a:t>000660</a:t>
+              <a:t>010010</a:t>
             </a:r>
             <a:endParaRPr lang="ko-KR" sz="1100"/>
           </a:p>
@@ -11485,7 +11485,7 @@
                 <a:latin typeface="Malgun Gothic"/>
                 <a:ea typeface="Malgun Gothic"/>
               </a:rPr>
-              <a:t>25.01%</a:t>
+              <a:t>100.00%</a:t>
             </a:r>
             <a:endParaRPr lang="ko-KR" sz="1100"/>
           </a:p>
@@ -11554,7 +11554,7 @@
                 <a:latin typeface="Malgun Gothic"/>
                 <a:ea typeface="Malgun Gothic"/>
               </a:rPr>
-              <a:t>0.00%</a:t>
+              <a:t>-</a:t>
             </a:r>
             <a:endParaRPr lang="ko-KR" sz="1100"/>
           </a:p>
@@ -11623,7 +11623,7 @@
                 <a:latin typeface="Malgun Gothic"/>
                 <a:ea typeface="Malgun Gothic"/>
               </a:rPr>
-              <a:t>-25.01pp</a:t>
+              <a:t>-100.00pp</a:t>
             </a:r>
             <a:endParaRPr lang="ko-KR" sz="1100"/>
           </a:p>
@@ -11849,7 +11849,7 @@
                 <a:latin typeface="Malgun Gothic"/>
                 <a:ea typeface="Malgun Gothic"/>
               </a:rPr>
-              <a:t>1. 오늘 변화 ETF는 105개, 전체 변화는 5165건입니다.</a:t>
+              <a:t>1. 오늘 변화 ETF는 252개, 전체 변화는 20877건입니다.</a:t>
             </a:r>
             <a:endParaRPr lang="ko-KR" sz="2400"/>
           </a:p>
@@ -11863,7 +11863,7 @@
                 <a:latin typeface="Malgun Gothic"/>
                 <a:ea typeface="Malgun Gothic"/>
               </a:rPr>
-              <a:t>2. 매수/비중증가 71건, 매도/비중감소 3474건을 확인했습니다.</a:t>
+              <a:t>2. 매수/비중증가 107건, 매도/비중감소 2301건을 확인했습니다.</a:t>
             </a:r>
             <a:endParaRPr lang="ko-KR" sz="2400"/>
           </a:p>

</xml_diff>

<commit_message>
Add new ETF entry tracking and update schedule
</commit_message>
<xml_diff>
--- a/docs/latest_changes.pptx
+++ b/docs/latest_changes.pptx
@@ -374,7 +374,7 @@
                 <a:latin typeface="Malgun Gothic"/>
                 <a:ea typeface="Malgun Gothic"/>
               </a:rPr>
-              <a:t>300</a:t>
+              <a:t>215</a:t>
             </a:r>
             <a:endParaRPr lang="ko-KR" sz="3000"/>
           </a:p>
@@ -512,7 +512,7 @@
                 <a:latin typeface="Malgun Gothic"/>
                 <a:ea typeface="Malgun Gothic"/>
               </a:rPr>
-              <a:t>251</a:t>
+              <a:t>72</a:t>
             </a:r>
             <a:endParaRPr lang="ko-KR" sz="3000"/>
           </a:p>
@@ -650,7 +650,7 @@
                 <a:latin typeface="Malgun Gothic"/>
                 <a:ea typeface="Malgun Gothic"/>
               </a:rPr>
-              <a:t>19361</a:t>
+              <a:t>994</a:t>
             </a:r>
             <a:endParaRPr lang="ko-KR" sz="3000"/>
           </a:p>
@@ -788,7 +788,7 @@
                 <a:latin typeface="Malgun Gothic"/>
                 <a:ea typeface="Malgun Gothic"/>
               </a:rPr>
-              <a:t>317</a:t>
+              <a:t>438</a:t>
             </a:r>
             <a:endParaRPr lang="ko-KR" sz="3000"/>
           </a:p>
@@ -926,7 +926,7 @@
                 <a:latin typeface="Malgun Gothic"/>
                 <a:ea typeface="Malgun Gothic"/>
               </a:rPr>
-              <a:t>587</a:t>
+              <a:t>540</a:t>
             </a:r>
             <a:endParaRPr lang="ko-KR" sz="3000"/>
           </a:p>
@@ -1315,7 +1315,7 @@
                 <a:latin typeface="Malgun Gothic"/>
                 <a:ea typeface="Malgun Gothic"/>
               </a:rPr>
-              <a:t>ACE 2차전지&amp;친환경차액티브 (385600)</a:t>
+              <a:t>VITA MZ소비액티브 (422260)</a:t>
             </a:r>
             <a:endParaRPr lang="ko-KR" sz="1800"/>
           </a:p>
@@ -1355,7 +1355,7 @@
                 <a:latin typeface="Malgun Gothic"/>
                 <a:ea typeface="Malgun Gothic"/>
               </a:rPr>
-              <a:t>변화 51건 | 매수/증가 0건 | 매도/감소 51건</a:t>
+              <a:t>변화 15건 | 매수/증가 4건 | 매도/감소 11건</a:t>
             </a:r>
             <a:endParaRPr lang="ko-KR" sz="1300"/>
           </a:p>
@@ -1395,7 +1395,7 @@
                 <a:latin typeface="Malgun Gothic"/>
                 <a:ea typeface="Malgun Gothic"/>
               </a:rPr>
-              <a:t>충격도 100.01pp</a:t>
+              <a:t>충격도 25.39pp</a:t>
             </a:r>
             <a:endParaRPr lang="ko-KR" sz="1800"/>
           </a:p>
@@ -1504,7 +1504,7 @@
                 <a:latin typeface="Malgun Gothic"/>
                 <a:ea typeface="Malgun Gothic"/>
               </a:rPr>
-              <a:t>ACE ESG액티브 (385590)</a:t>
+              <a:t>VITA 밸류알파액티브 (452440)</a:t>
             </a:r>
             <a:endParaRPr lang="ko-KR" sz="1800"/>
           </a:p>
@@ -1544,7 +1544,7 @@
                 <a:latin typeface="Malgun Gothic"/>
                 <a:ea typeface="Malgun Gothic"/>
               </a:rPr>
-              <a:t>변화 27건 | 매수/증가 0건 | 매도/감소 27건</a:t>
+              <a:t>변화 20건 | 매수/증가 4건 | 매도/감소 16건</a:t>
             </a:r>
             <a:endParaRPr lang="ko-KR" sz="1300"/>
           </a:p>
@@ -1584,7 +1584,7 @@
                 <a:latin typeface="Malgun Gothic"/>
                 <a:ea typeface="Malgun Gothic"/>
               </a:rPr>
-              <a:t>충격도 100.00pp</a:t>
+              <a:t>충격도 19.58pp</a:t>
             </a:r>
             <a:endParaRPr lang="ko-KR" sz="1800"/>
           </a:p>
@@ -1693,7 +1693,7 @@
                 <a:latin typeface="Malgun Gothic"/>
                 <a:ea typeface="Malgun Gothic"/>
               </a:rPr>
-              <a:t>1Q CD금리액티브(합성) (491610)</a:t>
+              <a:t>TIGER 퓨처모빌리티액티브 (387280)</a:t>
             </a:r>
             <a:endParaRPr lang="ko-KR" sz="1800"/>
           </a:p>
@@ -1733,7 +1733,7 @@
                 <a:latin typeface="Malgun Gothic"/>
                 <a:ea typeface="Malgun Gothic"/>
               </a:rPr>
-              <a:t>변화 7건 | 매수/증가 0건 | 매도/감소 1건</a:t>
+              <a:t>변화 21건 | 매수/증가 7건 | 매도/감소 14건</a:t>
             </a:r>
             <a:endParaRPr lang="ko-KR" sz="1300"/>
           </a:p>
@@ -1773,7 +1773,7 @@
                 <a:latin typeface="Malgun Gothic"/>
                 <a:ea typeface="Malgun Gothic"/>
               </a:rPr>
-              <a:t>충격도 100.00pp</a:t>
+              <a:t>충격도 15.48pp</a:t>
             </a:r>
             <a:endParaRPr lang="ko-KR" sz="1800"/>
           </a:p>
@@ -1882,7 +1882,7 @@
                 <a:latin typeface="Malgun Gothic"/>
                 <a:ea typeface="Malgun Gothic"/>
               </a:rPr>
-              <a:t>ACE 라이프자산주주가치액티브 (494330)</a:t>
+              <a:t>RISE 바이오TOP10액티브 (0000Z0)</a:t>
             </a:r>
             <a:endParaRPr lang="ko-KR" sz="1800"/>
           </a:p>
@@ -1922,7 +1922,7 @@
                 <a:latin typeface="Malgun Gothic"/>
                 <a:ea typeface="Malgun Gothic"/>
               </a:rPr>
-              <a:t>변화 31건 | 매수/증가 0건 | 매도/감소 31건</a:t>
+              <a:t>변화 18건 | 매수/증가 10건 | 매도/감소 8건</a:t>
             </a:r>
             <a:endParaRPr lang="ko-KR" sz="1300"/>
           </a:p>
@@ -1962,7 +1962,7 @@
                 <a:latin typeface="Malgun Gothic"/>
                 <a:ea typeface="Malgun Gothic"/>
               </a:rPr>
-              <a:t>충격도 100.00pp</a:t>
+              <a:t>충격도 12.44pp</a:t>
             </a:r>
             <a:endParaRPr lang="ko-KR" sz="1800"/>
           </a:p>
@@ -2071,7 +2071,7 @@
                 <a:latin typeface="Malgun Gothic"/>
                 <a:ea typeface="Malgun Gothic"/>
               </a:rPr>
-              <a:t>ACE K수출핵심TOP10산업액티브 (0172Y0)</a:t>
+              <a:t>KoAct AI인프라액티브 (487130)</a:t>
             </a:r>
             <a:endParaRPr lang="ko-KR" sz="1800"/>
           </a:p>
@@ -2111,7 +2111,7 @@
                 <a:latin typeface="Malgun Gothic"/>
                 <a:ea typeface="Malgun Gothic"/>
               </a:rPr>
-              <a:t>변화 13건 | 매수/증가 0건 | 매도/감소 13건</a:t>
+              <a:t>변화 23건 | 매수/증가 9건 | 매도/감소 14건</a:t>
             </a:r>
             <a:endParaRPr lang="ko-KR" sz="1300"/>
           </a:p>
@@ -2151,7 +2151,7 @@
                 <a:latin typeface="Malgun Gothic"/>
                 <a:ea typeface="Malgun Gothic"/>
               </a:rPr>
-              <a:t>충격도 99.99pp</a:t>
+              <a:t>충격도 10.74pp</a:t>
             </a:r>
             <a:endParaRPr lang="ko-KR" sz="1800"/>
           </a:p>
@@ -3092,7 +3092,7 @@
                 <a:latin typeface="Malgun Gothic"/>
                 <a:ea typeface="Malgun Gothic"/>
               </a:rPr>
-              <a:t>13.73%</a:t>
+              <a:t>13.76%</a:t>
             </a:r>
             <a:endParaRPr lang="ko-KR" sz="1100"/>
           </a:p>
@@ -3161,7 +3161,7 @@
                 <a:latin typeface="Malgun Gothic"/>
                 <a:ea typeface="Malgun Gothic"/>
               </a:rPr>
-              <a:t>+11.39pp</a:t>
+              <a:t>+11.42pp</a:t>
             </a:r>
             <a:endParaRPr lang="ko-KR" sz="1100"/>
           </a:p>
@@ -3506,7 +3506,7 @@
                 <a:latin typeface="Malgun Gothic"/>
                 <a:ea typeface="Malgun Gothic"/>
               </a:rPr>
-              <a:t>18.08%</a:t>
+              <a:t>18.03%</a:t>
             </a:r>
             <a:endParaRPr lang="ko-KR" sz="1100"/>
           </a:p>
@@ -3575,7 +3575,7 @@
                 <a:latin typeface="Malgun Gothic"/>
                 <a:ea typeface="Malgun Gothic"/>
               </a:rPr>
-              <a:t>+9.56pp</a:t>
+              <a:t>+9.51pp</a:t>
             </a:r>
             <a:endParaRPr lang="ko-KR" sz="1100"/>
           </a:p>
@@ -3851,7 +3851,7 @@
                 <a:latin typeface="Malgun Gothic"/>
                 <a:ea typeface="Malgun Gothic"/>
               </a:rPr>
-              <a:t>-</a:t>
+              <a:t>0.00%</a:t>
             </a:r>
             <a:endParaRPr lang="ko-KR" sz="1100"/>
           </a:p>
@@ -3920,7 +3920,7 @@
                 <a:latin typeface="Malgun Gothic"/>
                 <a:ea typeface="Malgun Gothic"/>
               </a:rPr>
-              <a:t>4.00%</a:t>
+              <a:t>3.97%</a:t>
             </a:r>
             <a:endParaRPr lang="ko-KR" sz="1100"/>
           </a:p>
@@ -3989,7 +3989,7 @@
                 <a:latin typeface="Malgun Gothic"/>
                 <a:ea typeface="Malgun Gothic"/>
               </a:rPr>
-              <a:t>+4.00pp</a:t>
+              <a:t>+3.97pp</a:t>
             </a:r>
             <a:endParaRPr lang="ko-KR" sz="1100"/>
           </a:p>
@@ -4058,7 +4058,7 @@
                 <a:latin typeface="Malgun Gothic"/>
                 <a:ea typeface="Malgun Gothic"/>
               </a:rPr>
-              <a:t>TIME K바이오액티브</a:t>
+              <a:t>에셋플러스 코리아대장장이액티브</a:t>
             </a:r>
             <a:endParaRPr lang="ko-KR" sz="1100"/>
           </a:p>
@@ -4265,7 +4265,7 @@
                 <a:latin typeface="Malgun Gothic"/>
                 <a:ea typeface="Malgun Gothic"/>
               </a:rPr>
-              <a:t>0.79%</a:t>
+              <a:t>7.62%</a:t>
             </a:r>
             <a:endParaRPr lang="ko-KR" sz="1100"/>
           </a:p>
@@ -4334,7 +4334,7 @@
                 <a:latin typeface="Malgun Gothic"/>
                 <a:ea typeface="Malgun Gothic"/>
               </a:rPr>
-              <a:t>2.71%</a:t>
+              <a:t>10.71%</a:t>
             </a:r>
             <a:endParaRPr lang="ko-KR" sz="1100"/>
           </a:p>
@@ -4403,7 +4403,7 @@
                 <a:latin typeface="Malgun Gothic"/>
                 <a:ea typeface="Malgun Gothic"/>
               </a:rPr>
-              <a:t>+1.92pp</a:t>
+              <a:t>+3.09pp</a:t>
             </a:r>
             <a:endParaRPr lang="ko-KR" sz="1100"/>
           </a:p>
@@ -4472,7 +4472,7 @@
                 <a:latin typeface="Malgun Gothic"/>
                 <a:ea typeface="Malgun Gothic"/>
               </a:rPr>
-              <a:t>RISE 바이오TOP10액티브</a:t>
+              <a:t>TIME K바이오액티브</a:t>
             </a:r>
             <a:endParaRPr lang="ko-KR" sz="1100"/>
           </a:p>
@@ -4541,7 +4541,7 @@
                 <a:latin typeface="Malgun Gothic"/>
                 <a:ea typeface="Malgun Gothic"/>
               </a:rPr>
-              <a:t>신규 토모큐브</a:t>
+              <a:t>증가 원화현금</a:t>
             </a:r>
             <a:endParaRPr lang="ko-KR" sz="1100"/>
           </a:p>
@@ -4610,7 +4610,7 @@
                 <a:latin typeface="Malgun Gothic"/>
                 <a:ea typeface="Malgun Gothic"/>
               </a:rPr>
-              <a:t>475960</a:t>
+              <a:t>010010</a:t>
             </a:r>
             <a:endParaRPr lang="ko-KR" sz="1100"/>
           </a:p>
@@ -4679,7 +4679,7 @@
                 <a:latin typeface="Malgun Gothic"/>
                 <a:ea typeface="Malgun Gothic"/>
               </a:rPr>
-              <a:t>-</a:t>
+              <a:t>0.79%</a:t>
             </a:r>
             <a:endParaRPr lang="ko-KR" sz="1100"/>
           </a:p>
@@ -4748,7 +4748,7 @@
                 <a:latin typeface="Malgun Gothic"/>
                 <a:ea typeface="Malgun Gothic"/>
               </a:rPr>
-              <a:t>1.77%</a:t>
+              <a:t>2.76%</a:t>
             </a:r>
             <a:endParaRPr lang="ko-KR" sz="1100"/>
           </a:p>
@@ -4817,7 +4817,7 @@
                 <a:latin typeface="Malgun Gothic"/>
                 <a:ea typeface="Malgun Gothic"/>
               </a:rPr>
-              <a:t>+1.77pp</a:t>
+              <a:t>+1.97pp</a:t>
             </a:r>
             <a:endParaRPr lang="ko-KR" sz="1100"/>
           </a:p>
@@ -4886,7 +4886,7 @@
                 <a:latin typeface="Malgun Gothic"/>
                 <a:ea typeface="Malgun Gothic"/>
               </a:rPr>
-              <a:t>TIME 코스피액티브</a:t>
+              <a:t>RISE 바이오TOP10액티브</a:t>
             </a:r>
             <a:endParaRPr lang="ko-KR" sz="1100"/>
           </a:p>
@@ -4955,7 +4955,7 @@
                 <a:latin typeface="Malgun Gothic"/>
                 <a:ea typeface="Malgun Gothic"/>
               </a:rPr>
-              <a:t>신규 신세계</a:t>
+              <a:t>신규 토모큐브</a:t>
             </a:r>
             <a:endParaRPr lang="ko-KR" sz="1100"/>
           </a:p>
@@ -5024,7 +5024,7 @@
                 <a:latin typeface="Malgun Gothic"/>
                 <a:ea typeface="Malgun Gothic"/>
               </a:rPr>
-              <a:t>004170</a:t>
+              <a:t>475960</a:t>
             </a:r>
             <a:endParaRPr lang="ko-KR" sz="1100"/>
           </a:p>
@@ -5093,7 +5093,7 @@
                 <a:latin typeface="Malgun Gothic"/>
                 <a:ea typeface="Malgun Gothic"/>
               </a:rPr>
-              <a:t>-</a:t>
+              <a:t>0.00%</a:t>
             </a:r>
             <a:endParaRPr lang="ko-KR" sz="1100"/>
           </a:p>
@@ -5162,7 +5162,7 @@
                 <a:latin typeface="Malgun Gothic"/>
                 <a:ea typeface="Malgun Gothic"/>
               </a:rPr>
-              <a:t>1.60%</a:t>
+              <a:t>1.80%</a:t>
             </a:r>
             <a:endParaRPr lang="ko-KR" sz="1100"/>
           </a:p>
@@ -5231,7 +5231,7 @@
                 <a:latin typeface="Malgun Gothic"/>
                 <a:ea typeface="Malgun Gothic"/>
               </a:rPr>
-              <a:t>+1.60pp</a:t>
+              <a:t>+1.80pp</a:t>
             </a:r>
             <a:endParaRPr lang="ko-KR" sz="1100"/>
           </a:p>
@@ -5300,7 +5300,7 @@
                 <a:latin typeface="Malgun Gothic"/>
                 <a:ea typeface="Malgun Gothic"/>
               </a:rPr>
-              <a:t>KoAct AI인프라액티브</a:t>
+              <a:t>RISE 바이오TOP10액티브</a:t>
             </a:r>
             <a:endParaRPr lang="ko-KR" sz="1100"/>
           </a:p>
@@ -5369,7 +5369,7 @@
                 <a:latin typeface="Malgun Gothic"/>
                 <a:ea typeface="Malgun Gothic"/>
               </a:rPr>
-              <a:t>신규 프로텍</a:t>
+              <a:t>증가 알테오젠</a:t>
             </a:r>
             <a:endParaRPr lang="ko-KR" sz="1100"/>
           </a:p>
@@ -5438,7 +5438,7 @@
                 <a:latin typeface="Malgun Gothic"/>
                 <a:ea typeface="Malgun Gothic"/>
               </a:rPr>
-              <a:t>053610</a:t>
+              <a:t>196170</a:t>
             </a:r>
             <a:endParaRPr lang="ko-KR" sz="1100"/>
           </a:p>
@@ -5507,7 +5507,7 @@
                 <a:latin typeface="Malgun Gothic"/>
                 <a:ea typeface="Malgun Gothic"/>
               </a:rPr>
-              <a:t>-</a:t>
+              <a:t>6.21%</a:t>
             </a:r>
             <a:endParaRPr lang="ko-KR" sz="1100"/>
           </a:p>
@@ -5576,7 +5576,7 @@
                 <a:latin typeface="Malgun Gothic"/>
                 <a:ea typeface="Malgun Gothic"/>
               </a:rPr>
-              <a:t>1.59%</a:t>
+              <a:t>7.80%</a:t>
             </a:r>
             <a:endParaRPr lang="ko-KR" sz="1100"/>
           </a:p>
@@ -5714,7 +5714,7 @@
                 <a:latin typeface="Malgun Gothic"/>
                 <a:ea typeface="Malgun Gothic"/>
               </a:rPr>
-              <a:t>RISE 바이오TOP10액티브</a:t>
+              <a:t>TIME 코스피액티브</a:t>
             </a:r>
             <a:endParaRPr lang="ko-KR" sz="1100"/>
           </a:p>
@@ -5783,7 +5783,7 @@
                 <a:latin typeface="Malgun Gothic"/>
                 <a:ea typeface="Malgun Gothic"/>
               </a:rPr>
-              <a:t>증가 알테오젠</a:t>
+              <a:t>신규 신세계</a:t>
             </a:r>
             <a:endParaRPr lang="ko-KR" sz="1100"/>
           </a:p>
@@ -5852,7 +5852,7 @@
                 <a:latin typeface="Malgun Gothic"/>
                 <a:ea typeface="Malgun Gothic"/>
               </a:rPr>
-              <a:t>196170</a:t>
+              <a:t>004170</a:t>
             </a:r>
             <a:endParaRPr lang="ko-KR" sz="1100"/>
           </a:p>
@@ -5921,7 +5921,7 @@
                 <a:latin typeface="Malgun Gothic"/>
                 <a:ea typeface="Malgun Gothic"/>
               </a:rPr>
-              <a:t>6.21%</a:t>
+              <a:t>0.00%</a:t>
             </a:r>
             <a:endParaRPr lang="ko-KR" sz="1100"/>
           </a:p>
@@ -5990,7 +5990,7 @@
                 <a:latin typeface="Malgun Gothic"/>
                 <a:ea typeface="Malgun Gothic"/>
               </a:rPr>
-              <a:t>7.68%</a:t>
+              <a:t>1.57%</a:t>
             </a:r>
             <a:endParaRPr lang="ko-KR" sz="1100"/>
           </a:p>
@@ -6059,7 +6059,7 @@
                 <a:latin typeface="Malgun Gothic"/>
                 <a:ea typeface="Malgun Gothic"/>
               </a:rPr>
-              <a:t>+1.47pp</a:t>
+              <a:t>+1.57pp</a:t>
             </a:r>
             <a:endParaRPr lang="ko-KR" sz="1100"/>
           </a:p>
@@ -6197,7 +6197,7 @@
                 <a:latin typeface="Malgun Gothic"/>
                 <a:ea typeface="Malgun Gothic"/>
               </a:rPr>
-              <a:t>증가 삼성SDI</a:t>
+              <a:t>신규 프로텍</a:t>
             </a:r>
             <a:endParaRPr lang="ko-KR" sz="1100"/>
           </a:p>
@@ -6266,7 +6266,7 @@
                 <a:latin typeface="Malgun Gothic"/>
                 <a:ea typeface="Malgun Gothic"/>
               </a:rPr>
-              <a:t>006400</a:t>
+              <a:t>053610</a:t>
             </a:r>
             <a:endParaRPr lang="ko-KR" sz="1100"/>
           </a:p>
@@ -6335,7 +6335,7 @@
                 <a:latin typeface="Malgun Gothic"/>
                 <a:ea typeface="Malgun Gothic"/>
               </a:rPr>
-              <a:t>6.49%</a:t>
+              <a:t>0.00%</a:t>
             </a:r>
             <a:endParaRPr lang="ko-KR" sz="1100"/>
           </a:p>
@@ -6404,7 +6404,7 @@
                 <a:latin typeface="Malgun Gothic"/>
                 <a:ea typeface="Malgun Gothic"/>
               </a:rPr>
-              <a:t>7.77%</a:t>
+              <a:t>1.55%</a:t>
             </a:r>
             <a:endParaRPr lang="ko-KR" sz="1100"/>
           </a:p>
@@ -6473,7 +6473,7 @@
                 <a:latin typeface="Malgun Gothic"/>
                 <a:ea typeface="Malgun Gothic"/>
               </a:rPr>
-              <a:t>+1.28pp</a:t>
+              <a:t>+1.55pp</a:t>
             </a:r>
             <a:endParaRPr lang="ko-KR" sz="1100"/>
           </a:p>
@@ -6818,7 +6818,7 @@
                 <a:latin typeface="Malgun Gothic"/>
                 <a:ea typeface="Malgun Gothic"/>
               </a:rPr>
-              <a:t>4.14%</a:t>
+              <a:t>4.27%</a:t>
             </a:r>
             <a:endParaRPr lang="ko-KR" sz="1100"/>
           </a:p>
@@ -6887,7 +6887,7 @@
                 <a:latin typeface="Malgun Gothic"/>
                 <a:ea typeface="Malgun Gothic"/>
               </a:rPr>
-              <a:t>+1.23pp</a:t>
+              <a:t>+1.36pp</a:t>
             </a:r>
             <a:endParaRPr lang="ko-KR" sz="1100"/>
           </a:p>
@@ -7552,7 +7552,7 @@
                 <a:latin typeface="Malgun Gothic"/>
                 <a:ea typeface="Malgun Gothic"/>
               </a:rPr>
-              <a:t>1Q CD금리액티브(합성)</a:t>
+              <a:t>VITA MZ소비액티브</a:t>
             </a:r>
             <a:endParaRPr lang="ko-KR" sz="1100"/>
           </a:p>
@@ -7621,7 +7621,7 @@
                 <a:latin typeface="Malgun Gothic"/>
                 <a:ea typeface="Malgun Gothic"/>
               </a:rPr>
-              <a:t>감소 원화현금</a:t>
+              <a:t>감소 에이피알</a:t>
             </a:r>
             <a:endParaRPr lang="ko-KR" sz="1100"/>
           </a:p>
@@ -7690,7 +7690,7 @@
                 <a:latin typeface="Malgun Gothic"/>
                 <a:ea typeface="Malgun Gothic"/>
               </a:rPr>
-              <a:t>010010</a:t>
+              <a:t>278470</a:t>
             </a:r>
             <a:endParaRPr lang="ko-KR" sz="1100"/>
           </a:p>
@@ -7759,7 +7759,7 @@
                 <a:latin typeface="Malgun Gothic"/>
                 <a:ea typeface="Malgun Gothic"/>
               </a:rPr>
-              <a:t>100.00%</a:t>
+              <a:t>9.94%</a:t>
             </a:r>
             <a:endParaRPr lang="ko-KR" sz="1100"/>
           </a:p>
@@ -7828,7 +7828,7 @@
                 <a:latin typeface="Malgun Gothic"/>
                 <a:ea typeface="Malgun Gothic"/>
               </a:rPr>
-              <a:t>-</a:t>
+              <a:t>6.77%</a:t>
             </a:r>
             <a:endParaRPr lang="ko-KR" sz="1100"/>
           </a:p>
@@ -7897,7 +7897,7 @@
                 <a:latin typeface="Malgun Gothic"/>
                 <a:ea typeface="Malgun Gothic"/>
               </a:rPr>
-              <a:t>-100.00pp</a:t>
+              <a:t>-3.17pp</a:t>
             </a:r>
             <a:endParaRPr lang="ko-KR" sz="1100"/>
           </a:p>
@@ -7966,7 +7966,7 @@
                 <a:latin typeface="Malgun Gothic"/>
                 <a:ea typeface="Malgun Gothic"/>
               </a:rPr>
-              <a:t>1Q 200액티브</a:t>
+              <a:t>KODEX 코리아혁신성장액티브</a:t>
             </a:r>
             <a:endParaRPr lang="ko-KR" sz="1100"/>
           </a:p>
@@ -8035,7 +8035,7 @@
                 <a:latin typeface="Malgun Gothic"/>
                 <a:ea typeface="Malgun Gothic"/>
               </a:rPr>
-              <a:t>감소 삼성전자</a:t>
+              <a:t>감소 셀트리온</a:t>
             </a:r>
             <a:endParaRPr lang="ko-KR" sz="1100"/>
           </a:p>
@@ -8104,7 +8104,7 @@
                 <a:latin typeface="Malgun Gothic"/>
                 <a:ea typeface="Malgun Gothic"/>
               </a:rPr>
-              <a:t>005930</a:t>
+              <a:t>068270</a:t>
             </a:r>
             <a:endParaRPr lang="ko-KR" sz="1100"/>
           </a:p>
@@ -8173,7 +8173,7 @@
                 <a:latin typeface="Malgun Gothic"/>
                 <a:ea typeface="Malgun Gothic"/>
               </a:rPr>
-              <a:t>31.62%</a:t>
+              <a:t>4.30%</a:t>
             </a:r>
             <a:endParaRPr lang="ko-KR" sz="1100"/>
           </a:p>
@@ -8242,7 +8242,7 @@
                 <a:latin typeface="Malgun Gothic"/>
                 <a:ea typeface="Malgun Gothic"/>
               </a:rPr>
-              <a:t>-</a:t>
+              <a:t>1.42%</a:t>
             </a:r>
             <a:endParaRPr lang="ko-KR" sz="1100"/>
           </a:p>
@@ -8311,7 +8311,7 @@
                 <a:latin typeface="Malgun Gothic"/>
                 <a:ea typeface="Malgun Gothic"/>
               </a:rPr>
-              <a:t>-31.62pp</a:t>
+              <a:t>-2.88pp</a:t>
             </a:r>
             <a:endParaRPr lang="ko-KR" sz="1100"/>
           </a:p>
@@ -8380,7 +8380,7 @@
                 <a:latin typeface="Malgun Gothic"/>
                 <a:ea typeface="Malgun Gothic"/>
               </a:rPr>
-              <a:t>ACE 라이프자산주주가치액티브</a:t>
+              <a:t>KoAct 수소전력ESS인프라액티</a:t>
             </a:r>
             <a:endParaRPr lang="ko-KR" sz="1100"/>
           </a:p>
@@ -8449,7 +8449,7 @@
                 <a:latin typeface="Malgun Gothic"/>
                 <a:ea typeface="Malgun Gothic"/>
               </a:rPr>
-              <a:t>감소 삼성전자</a:t>
+              <a:t>감소 LS ELECTRIC</a:t>
             </a:r>
             <a:endParaRPr lang="ko-KR" sz="1100"/>
           </a:p>
@@ -8518,7 +8518,7 @@
                 <a:latin typeface="Malgun Gothic"/>
                 <a:ea typeface="Malgun Gothic"/>
               </a:rPr>
-              <a:t>005930</a:t>
+              <a:t>010120</a:t>
             </a:r>
             <a:endParaRPr lang="ko-KR" sz="1100"/>
           </a:p>
@@ -8587,7 +8587,7 @@
                 <a:latin typeface="Malgun Gothic"/>
                 <a:ea typeface="Malgun Gothic"/>
               </a:rPr>
-              <a:t>25.13%</a:t>
+              <a:t>2.49%</a:t>
             </a:r>
             <a:endParaRPr lang="ko-KR" sz="1100"/>
           </a:p>
@@ -8656,7 +8656,7 @@
                 <a:latin typeface="Malgun Gothic"/>
                 <a:ea typeface="Malgun Gothic"/>
               </a:rPr>
-              <a:t>-</a:t>
+              <a:t>0.12%</a:t>
             </a:r>
             <a:endParaRPr lang="ko-KR" sz="1100"/>
           </a:p>
@@ -8725,7 +8725,7 @@
                 <a:latin typeface="Malgun Gothic"/>
                 <a:ea typeface="Malgun Gothic"/>
               </a:rPr>
-              <a:t>-25.13pp</a:t>
+              <a:t>-2.37pp</a:t>
             </a:r>
             <a:endParaRPr lang="ko-KR" sz="1100"/>
           </a:p>
@@ -8794,7 +8794,7 @@
                 <a:latin typeface="Malgun Gothic"/>
                 <a:ea typeface="Malgun Gothic"/>
               </a:rPr>
-              <a:t>ACE ESG액티브</a:t>
+              <a:t>ACE 주주환원가치주액티브</a:t>
             </a:r>
             <a:endParaRPr lang="ko-KR" sz="1100"/>
           </a:p>
@@ -8863,7 +8863,7 @@
                 <a:latin typeface="Malgun Gothic"/>
                 <a:ea typeface="Malgun Gothic"/>
               </a:rPr>
-              <a:t>감소 삼성전자</a:t>
+              <a:t>감소 나이스정보통신</a:t>
             </a:r>
             <a:endParaRPr lang="ko-KR" sz="1100"/>
           </a:p>
@@ -8932,7 +8932,7 @@
                 <a:latin typeface="Malgun Gothic"/>
                 <a:ea typeface="Malgun Gothic"/>
               </a:rPr>
-              <a:t>005930</a:t>
+              <a:t>036800</a:t>
             </a:r>
             <a:endParaRPr lang="ko-KR" sz="1100"/>
           </a:p>
@@ -9001,7 +9001,7 @@
                 <a:latin typeface="Malgun Gothic"/>
                 <a:ea typeface="Malgun Gothic"/>
               </a:rPr>
-              <a:t>22.53%</a:t>
+              <a:t>2.37%</a:t>
             </a:r>
             <a:endParaRPr lang="ko-KR" sz="1100"/>
           </a:p>
@@ -9070,7 +9070,7 @@
                 <a:latin typeface="Malgun Gothic"/>
                 <a:ea typeface="Malgun Gothic"/>
               </a:rPr>
-              <a:t>-</a:t>
+              <a:t>0.17%</a:t>
             </a:r>
             <a:endParaRPr lang="ko-KR" sz="1100"/>
           </a:p>
@@ -9139,7 +9139,7 @@
                 <a:latin typeface="Malgun Gothic"/>
                 <a:ea typeface="Malgun Gothic"/>
               </a:rPr>
-              <a:t>-22.53pp</a:t>
+              <a:t>-2.20pp</a:t>
             </a:r>
             <a:endParaRPr lang="ko-KR" sz="1100"/>
           </a:p>
@@ -9208,7 +9208,7 @@
                 <a:latin typeface="Malgun Gothic"/>
                 <a:ea typeface="Malgun Gothic"/>
               </a:rPr>
-              <a:t>1Q 200액티브</a:t>
+              <a:t>VITA 밸류알파액티브</a:t>
             </a:r>
             <a:endParaRPr lang="ko-KR" sz="1100"/>
           </a:p>
@@ -9277,7 +9277,7 @@
                 <a:latin typeface="Malgun Gothic"/>
                 <a:ea typeface="Malgun Gothic"/>
               </a:rPr>
-              <a:t>감소 SK하이닉스</a:t>
+              <a:t>감소 신세계</a:t>
             </a:r>
             <a:endParaRPr lang="ko-KR" sz="1100"/>
           </a:p>
@@ -9346,7 +9346,7 @@
                 <a:latin typeface="Malgun Gothic"/>
                 <a:ea typeface="Malgun Gothic"/>
               </a:rPr>
-              <a:t>000660</a:t>
+              <a:t>004170</a:t>
             </a:r>
             <a:endParaRPr lang="ko-KR" sz="1100"/>
           </a:p>
@@ -9415,7 +9415,7 @@
                 <a:latin typeface="Malgun Gothic"/>
                 <a:ea typeface="Malgun Gothic"/>
               </a:rPr>
-              <a:t>21.03%</a:t>
+              <a:t>7.24%</a:t>
             </a:r>
             <a:endParaRPr lang="ko-KR" sz="1100"/>
           </a:p>
@@ -9484,7 +9484,7 @@
                 <a:latin typeface="Malgun Gothic"/>
                 <a:ea typeface="Malgun Gothic"/>
               </a:rPr>
-              <a:t>-</a:t>
+              <a:t>5.13%</a:t>
             </a:r>
             <a:endParaRPr lang="ko-KR" sz="1100"/>
           </a:p>
@@ -9553,7 +9553,7 @@
                 <a:latin typeface="Malgun Gothic"/>
                 <a:ea typeface="Malgun Gothic"/>
               </a:rPr>
-              <a:t>-21.03pp</a:t>
+              <a:t>-2.11pp</a:t>
             </a:r>
             <a:endParaRPr lang="ko-KR" sz="1100"/>
           </a:p>
@@ -9622,7 +9622,7 @@
                 <a:latin typeface="Malgun Gothic"/>
                 <a:ea typeface="Malgun Gothic"/>
               </a:rPr>
-              <a:t>ACE ESG액티브</a:t>
+              <a:t>ACE 주주환원가치주액티브</a:t>
             </a:r>
             <a:endParaRPr lang="ko-KR" sz="1100"/>
           </a:p>
@@ -9691,7 +9691,7 @@
                 <a:latin typeface="Malgun Gothic"/>
                 <a:ea typeface="Malgun Gothic"/>
               </a:rPr>
-              <a:t>감소 SK하이닉스</a:t>
+              <a:t>감소 현대홈쇼핑</a:t>
             </a:r>
             <a:endParaRPr lang="ko-KR" sz="1100"/>
           </a:p>
@@ -9760,7 +9760,7 @@
                 <a:latin typeface="Malgun Gothic"/>
                 <a:ea typeface="Malgun Gothic"/>
               </a:rPr>
-              <a:t>000660</a:t>
+              <a:t>057050</a:t>
             </a:r>
             <a:endParaRPr lang="ko-KR" sz="1100"/>
           </a:p>
@@ -9829,7 +9829,7 @@
                 <a:latin typeface="Malgun Gothic"/>
                 <a:ea typeface="Malgun Gothic"/>
               </a:rPr>
-              <a:t>14.22%</a:t>
+              <a:t>2.36%</a:t>
             </a:r>
             <a:endParaRPr lang="ko-KR" sz="1100"/>
           </a:p>
@@ -9898,7 +9898,7 @@
                 <a:latin typeface="Malgun Gothic"/>
                 <a:ea typeface="Malgun Gothic"/>
               </a:rPr>
-              <a:t>-</a:t>
+              <a:t>0.31%</a:t>
             </a:r>
             <a:endParaRPr lang="ko-KR" sz="1100"/>
           </a:p>
@@ -9967,7 +9967,7 @@
                 <a:latin typeface="Malgun Gothic"/>
                 <a:ea typeface="Malgun Gothic"/>
               </a:rPr>
-              <a:t>-14.22pp</a:t>
+              <a:t>-2.05pp</a:t>
             </a:r>
             <a:endParaRPr lang="ko-KR" sz="1100"/>
           </a:p>
@@ -10036,7 +10036,7 @@
                 <a:latin typeface="Malgun Gothic"/>
                 <a:ea typeface="Malgun Gothic"/>
               </a:rPr>
-              <a:t>ACE 2차전지&amp;친환경차액티브</a:t>
+              <a:t>VITA MZ소비액티브</a:t>
             </a:r>
             <a:endParaRPr lang="ko-KR" sz="1100"/>
           </a:p>
@@ -10105,7 +10105,7 @@
                 <a:latin typeface="Malgun Gothic"/>
                 <a:ea typeface="Malgun Gothic"/>
               </a:rPr>
-              <a:t>감소 삼성전기</a:t>
+              <a:t>감소 파라다이스</a:t>
             </a:r>
             <a:endParaRPr lang="ko-KR" sz="1100"/>
           </a:p>
@@ -10174,7 +10174,7 @@
                 <a:latin typeface="Malgun Gothic"/>
                 <a:ea typeface="Malgun Gothic"/>
               </a:rPr>
-              <a:t>009150</a:t>
+              <a:t>034230</a:t>
             </a:r>
             <a:endParaRPr lang="ko-KR" sz="1100"/>
           </a:p>
@@ -10243,7 +10243,7 @@
                 <a:latin typeface="Malgun Gothic"/>
                 <a:ea typeface="Malgun Gothic"/>
               </a:rPr>
-              <a:t>12.44%</a:t>
+              <a:t>7.00%</a:t>
             </a:r>
             <a:endParaRPr lang="ko-KR" sz="1100"/>
           </a:p>
@@ -10312,7 +10312,7 @@
                 <a:latin typeface="Malgun Gothic"/>
                 <a:ea typeface="Malgun Gothic"/>
               </a:rPr>
-              <a:t>-</a:t>
+              <a:t>4.96%</a:t>
             </a:r>
             <a:endParaRPr lang="ko-KR" sz="1100"/>
           </a:p>
@@ -10381,7 +10381,7 @@
                 <a:latin typeface="Malgun Gothic"/>
                 <a:ea typeface="Malgun Gothic"/>
               </a:rPr>
-              <a:t>-12.44pp</a:t>
+              <a:t>-2.04pp</a:t>
             </a:r>
             <a:endParaRPr lang="ko-KR" sz="1100"/>
           </a:p>
@@ -10450,7 +10450,7 @@
                 <a:latin typeface="Malgun Gothic"/>
                 <a:ea typeface="Malgun Gothic"/>
               </a:rPr>
-              <a:t>ACE K수출핵심TOP10산업액티</a:t>
+              <a:t>VITA MZ소비액티브</a:t>
             </a:r>
             <a:endParaRPr lang="ko-KR" sz="1100"/>
           </a:p>
@@ -10519,7 +10519,7 @@
                 <a:latin typeface="Malgun Gothic"/>
                 <a:ea typeface="Malgun Gothic"/>
               </a:rPr>
-              <a:t>감소 에이피알</a:t>
+              <a:t>감소 아모레퍼시픽</a:t>
             </a:r>
             <a:endParaRPr lang="ko-KR" sz="1100"/>
           </a:p>
@@ -10588,7 +10588,7 @@
                 <a:latin typeface="Malgun Gothic"/>
                 <a:ea typeface="Malgun Gothic"/>
               </a:rPr>
-              <a:t>278470</a:t>
+              <a:t>090430</a:t>
             </a:r>
             <a:endParaRPr lang="ko-KR" sz="1100"/>
           </a:p>
@@ -10657,7 +10657,7 @@
                 <a:latin typeface="Malgun Gothic"/>
                 <a:ea typeface="Malgun Gothic"/>
               </a:rPr>
-              <a:t>10.41%</a:t>
+              <a:t>8.10%</a:t>
             </a:r>
             <a:endParaRPr lang="ko-KR" sz="1100"/>
           </a:p>
@@ -10726,7 +10726,7 @@
                 <a:latin typeface="Malgun Gothic"/>
                 <a:ea typeface="Malgun Gothic"/>
               </a:rPr>
-              <a:t>-</a:t>
+              <a:t>6.07%</a:t>
             </a:r>
             <a:endParaRPr lang="ko-KR" sz="1100"/>
           </a:p>
@@ -10795,7 +10795,7 @@
                 <a:latin typeface="Malgun Gothic"/>
                 <a:ea typeface="Malgun Gothic"/>
               </a:rPr>
-              <a:t>-10.41pp</a:t>
+              <a:t>-2.03pp</a:t>
             </a:r>
             <a:endParaRPr lang="ko-KR" sz="1100"/>
           </a:p>
@@ -10864,7 +10864,7 @@
                 <a:latin typeface="Malgun Gothic"/>
                 <a:ea typeface="Malgun Gothic"/>
               </a:rPr>
-              <a:t>ACE 2차전지&amp;친환경차액티브</a:t>
+              <a:t>RISE 바이오TOP10액티브</a:t>
             </a:r>
             <a:endParaRPr lang="ko-KR" sz="1100"/>
           </a:p>
@@ -10933,7 +10933,7 @@
                 <a:latin typeface="Malgun Gothic"/>
                 <a:ea typeface="Malgun Gothic"/>
               </a:rPr>
-              <a:t>감소 삼성SDI</a:t>
+              <a:t>제외 지놈앤컴퍼니</a:t>
             </a:r>
             <a:endParaRPr lang="ko-KR" sz="1100"/>
           </a:p>
@@ -11002,7 +11002,7 @@
                 <a:latin typeface="Malgun Gothic"/>
                 <a:ea typeface="Malgun Gothic"/>
               </a:rPr>
-              <a:t>006400</a:t>
+              <a:t>314130</a:t>
             </a:r>
             <a:endParaRPr lang="ko-KR" sz="1100"/>
           </a:p>
@@ -11071,7 +11071,7 @@
                 <a:latin typeface="Malgun Gothic"/>
                 <a:ea typeface="Malgun Gothic"/>
               </a:rPr>
-              <a:t>10.30%</a:t>
+              <a:t>1.93%</a:t>
             </a:r>
             <a:endParaRPr lang="ko-KR" sz="1100"/>
           </a:p>
@@ -11140,7 +11140,7 @@
                 <a:latin typeface="Malgun Gothic"/>
                 <a:ea typeface="Malgun Gothic"/>
               </a:rPr>
-              <a:t>-</a:t>
+              <a:t>0.00%</a:t>
             </a:r>
             <a:endParaRPr lang="ko-KR" sz="1100"/>
           </a:p>
@@ -11209,7 +11209,7 @@
                 <a:latin typeface="Malgun Gothic"/>
                 <a:ea typeface="Malgun Gothic"/>
               </a:rPr>
-              <a:t>-10.30pp</a:t>
+              <a:t>-1.93pp</a:t>
             </a:r>
             <a:endParaRPr lang="ko-KR" sz="1100"/>
           </a:p>
@@ -11278,7 +11278,7 @@
                 <a:latin typeface="Malgun Gothic"/>
                 <a:ea typeface="Malgun Gothic"/>
               </a:rPr>
-              <a:t>ACE K수출핵심TOP10산업액티</a:t>
+              <a:t>VITA 밸류알파액티브</a:t>
             </a:r>
             <a:endParaRPr lang="ko-KR" sz="1100"/>
           </a:p>
@@ -11347,7 +11347,7 @@
                 <a:latin typeface="Malgun Gothic"/>
                 <a:ea typeface="Malgun Gothic"/>
               </a:rPr>
-              <a:t>감소 HD현대일렉트릭</a:t>
+              <a:t>감소 아모레퍼시픽</a:t>
             </a:r>
             <a:endParaRPr lang="ko-KR" sz="1100"/>
           </a:p>
@@ -11416,7 +11416,7 @@
                 <a:latin typeface="Malgun Gothic"/>
                 <a:ea typeface="Malgun Gothic"/>
               </a:rPr>
-              <a:t>267260</a:t>
+              <a:t>090430</a:t>
             </a:r>
             <a:endParaRPr lang="ko-KR" sz="1100"/>
           </a:p>
@@ -11485,7 +11485,7 @@
                 <a:latin typeface="Malgun Gothic"/>
                 <a:ea typeface="Malgun Gothic"/>
               </a:rPr>
-              <a:t>9.78%</a:t>
+              <a:t>6.79%</a:t>
             </a:r>
             <a:endParaRPr lang="ko-KR" sz="1100"/>
           </a:p>
@@ -11554,7 +11554,7 @@
                 <a:latin typeface="Malgun Gothic"/>
                 <a:ea typeface="Malgun Gothic"/>
               </a:rPr>
-              <a:t>-</a:t>
+              <a:t>5.02%</a:t>
             </a:r>
             <a:endParaRPr lang="ko-KR" sz="1100"/>
           </a:p>
@@ -11623,7 +11623,7 @@
                 <a:latin typeface="Malgun Gothic"/>
                 <a:ea typeface="Malgun Gothic"/>
               </a:rPr>
-              <a:t>-9.78pp</a:t>
+              <a:t>-1.77pp</a:t>
             </a:r>
             <a:endParaRPr lang="ko-KR" sz="1100"/>
           </a:p>
@@ -11849,7 +11849,7 @@
                 <a:latin typeface="Malgun Gothic"/>
                 <a:ea typeface="Malgun Gothic"/>
               </a:rPr>
-              <a:t>1. 오늘 변화 ETF는 251개, 전체 변화는 19361건입니다.</a:t>
+              <a:t>1. 오늘 변화 ETF는 72개, 전체 변화는 994건입니다.</a:t>
             </a:r>
             <a:endParaRPr lang="ko-KR" sz="2400"/>
           </a:p>
@@ -11863,7 +11863,7 @@
                 <a:latin typeface="Malgun Gothic"/>
                 <a:ea typeface="Malgun Gothic"/>
               </a:rPr>
-              <a:t>2. 매수/비중증가 317건, 매도/비중감소 587건을 확인했습니다.</a:t>
+              <a:t>2. 매수/비중증가 438건, 매도/비중감소 540건을 확인했습니다.</a:t>
             </a:r>
             <a:endParaRPr lang="ko-KR" sz="2400"/>
           </a:p>

</xml_diff>

<commit_message>
Exclude government bond ETFs and highlight new entries
</commit_message>
<xml_diff>
--- a/docs/latest_changes.pptx
+++ b/docs/latest_changes.pptx
@@ -374,7 +374,7 @@
                 <a:latin typeface="Malgun Gothic"/>
                 <a:ea typeface="Malgun Gothic"/>
               </a:rPr>
-              <a:t>215</a:t>
+              <a:t>71</a:t>
             </a:r>
             <a:endParaRPr lang="ko-KR" sz="3000"/>
           </a:p>
@@ -512,7 +512,7 @@
                 <a:latin typeface="Malgun Gothic"/>
                 <a:ea typeface="Malgun Gothic"/>
               </a:rPr>
-              <a:t>72</a:t>
+              <a:t>71</a:t>
             </a:r>
             <a:endParaRPr lang="ko-KR" sz="3000"/>
           </a:p>
@@ -650,7 +650,7 @@
                 <a:latin typeface="Malgun Gothic"/>
                 <a:ea typeface="Malgun Gothic"/>
               </a:rPr>
-              <a:t>1018</a:t>
+              <a:t>1012</a:t>
             </a:r>
             <a:endParaRPr lang="ko-KR" sz="3000"/>
           </a:p>
@@ -5714,7 +5714,7 @@
                 <a:latin typeface="Malgun Gothic"/>
                 <a:ea typeface="Malgun Gothic"/>
               </a:rPr>
-              <a:t>KoAct AI인프라액티브</a:t>
+              <a:t>RISE 바이오TOP10액티브</a:t>
             </a:r>
             <a:endParaRPr lang="ko-KR" sz="1100"/>
           </a:p>
@@ -5783,7 +5783,7 @@
                 <a:latin typeface="Malgun Gothic"/>
                 <a:ea typeface="Malgun Gothic"/>
               </a:rPr>
-              <a:t>신규 프로텍</a:t>
+              <a:t>증가 알테오젠</a:t>
             </a:r>
             <a:endParaRPr lang="ko-KR" sz="1100"/>
           </a:p>
@@ -5852,7 +5852,7 @@
                 <a:latin typeface="Malgun Gothic"/>
                 <a:ea typeface="Malgun Gothic"/>
               </a:rPr>
-              <a:t>053610</a:t>
+              <a:t>196170</a:t>
             </a:r>
             <a:endParaRPr lang="ko-KR" sz="1100"/>
           </a:p>
@@ -5921,7 +5921,7 @@
                 <a:latin typeface="Malgun Gothic"/>
                 <a:ea typeface="Malgun Gothic"/>
               </a:rPr>
-              <a:t>0.00%</a:t>
+              <a:t>6.21%</a:t>
             </a:r>
             <a:endParaRPr lang="ko-KR" sz="1100"/>
           </a:p>
@@ -5990,7 +5990,7 @@
                 <a:latin typeface="Malgun Gothic"/>
                 <a:ea typeface="Malgun Gothic"/>
               </a:rPr>
-              <a:t>1.54%</a:t>
+              <a:t>7.75%</a:t>
             </a:r>
             <a:endParaRPr lang="ko-KR" sz="1100"/>
           </a:p>
@@ -6128,7 +6128,7 @@
                 <a:latin typeface="Malgun Gothic"/>
                 <a:ea typeface="Malgun Gothic"/>
               </a:rPr>
-              <a:t>RISE 바이오TOP10액티브</a:t>
+              <a:t>KoAct AI인프라액티브</a:t>
             </a:r>
             <a:endParaRPr lang="ko-KR" sz="1100"/>
           </a:p>
@@ -6197,7 +6197,7 @@
                 <a:latin typeface="Malgun Gothic"/>
                 <a:ea typeface="Malgun Gothic"/>
               </a:rPr>
-              <a:t>증가 알테오젠</a:t>
+              <a:t>신규 프로텍</a:t>
             </a:r>
             <a:endParaRPr lang="ko-KR" sz="1100"/>
           </a:p>
@@ -6266,7 +6266,7 @@
                 <a:latin typeface="Malgun Gothic"/>
                 <a:ea typeface="Malgun Gothic"/>
               </a:rPr>
-              <a:t>196170</a:t>
+              <a:t>053610</a:t>
             </a:r>
             <a:endParaRPr lang="ko-KR" sz="1100"/>
           </a:p>
@@ -6335,7 +6335,7 @@
                 <a:latin typeface="Malgun Gothic"/>
                 <a:ea typeface="Malgun Gothic"/>
               </a:rPr>
-              <a:t>6.21%</a:t>
+              <a:t>0.00%</a:t>
             </a:r>
             <a:endParaRPr lang="ko-KR" sz="1100"/>
           </a:p>
@@ -6404,7 +6404,7 @@
                 <a:latin typeface="Malgun Gothic"/>
                 <a:ea typeface="Malgun Gothic"/>
               </a:rPr>
-              <a:t>7.75%</a:t>
+              <a:t>1.54%</a:t>
             </a:r>
             <a:endParaRPr lang="ko-KR" sz="1100"/>
           </a:p>
@@ -11849,7 +11849,7 @@
                 <a:latin typeface="Malgun Gothic"/>
                 <a:ea typeface="Malgun Gothic"/>
               </a:rPr>
-              <a:t>1. 오늘 변화 ETF는 72개, 전체 변화는 1018건입니다.</a:t>
+              <a:t>1. 오늘 변화 ETF는 71개, 전체 변화는 1012건입니다.</a:t>
             </a:r>
             <a:endParaRPr lang="ko-KR" sz="2400"/>
           </a:p>

</xml_diff>